<commit_message>
proposal v2: rewrite Algorithm 1 around a single moving anchor; align deck
Co-Authored-By: Claude Fable 5.1 <noreply@anthropic.com>
</commit_message>
<xml_diff>
--- a/proposal/seminar_presentation.pptx
+++ b/proposal/seminar_presentation.pptx
@@ -121,12 +121,12 @@
   <p:extLst>
     <p:ext uri="{521415D9-36F7-43E2-AB2F-B90AF26B5E84}">
       <p14:sectionLst xmlns:p14="http://schemas.microsoft.com/office/powerpoint/2010/main">
-        <p14:section name="Opening" id="{c51deb47-349b-1af1-ae8e-111211282b2e}">
+        <p14:section name="Opening" id="{36b1907c-2e5d-6cc8-9df1-7380a97afc92}">
           <p14:sldIdLst>
             <p14:sldId id="256"/>
           </p14:sldIdLst>
         </p14:section>
-        <p14:section name="Background" id="{5b6d7c0c-155e-dc3e-ef38-5c00ddc866d7}">
+        <p14:section name="Background" id="{883b8a1e-9b76-417f-e755-36bca8d43ed9}">
           <p14:sldIdLst>
             <p14:sldId id="257"/>
             <p14:sldId id="258"/>
@@ -134,7 +134,7 @@
             <p14:sldId id="260"/>
           </p14:sldIdLst>
         </p14:section>
-        <p14:section name="Phase 1: benchmark and preliminary results" id="{bbb0bd72-ab7d-4930-0062-38a932ce3435}">
+        <p14:section name="Phase 1: benchmark and preliminary results" id="{b4e388bb-edd2-6f76-432a-7895c778382b}">
           <p14:sldIdLst>
             <p14:sldId id="261"/>
             <p14:sldId id="262"/>
@@ -142,7 +142,7 @@
             <p14:sldId id="264"/>
           </p14:sldIdLst>
         </p14:section>
-        <p14:section name="Research plan" id="{180cc898-129d-ed69-eb08-bfbc5f27d24d}">
+        <p14:section name="Research plan" id="{6aff8423-9c63-d822-a907-3bc503e1d270}">
           <p14:sldIdLst>
             <p14:sldId id="265"/>
             <p14:sldId id="266"/>
@@ -151,7 +151,7 @@
             <p14:sldId id="269"/>
           </p14:sldIdLst>
         </p14:section>
-        <p14:section name="Closing" id="{68038f8c-e08b-b109-47ca-4350ce2b5d95}">
+        <p14:section name="Closing" id="{b923617d-40d5-36fc-534e-2b95dfc2ff1f}">
           <p14:sldIdLst>
             <p14:sldId id="270"/>
           </p14:sldIdLst>
@@ -5997,7 +5997,7 @@
                   <a:schemeClr val="tx1"/>
                 </a:solidFill>
               </a:rPr>
-              <a:t>Highest α(t)·sim(d,Q) + (1−α(t))·sim(d,C(t)); α falls as evidence grows. Stop at the first 1.0 or at budget B.</a:t>
+              <a:t>The uninspected document nearest to the anchor A = normalize(a·Q + (1−a)·centroid(R)); a falls as R grows. Stop at the first 1.0 or at budget B.</a:t>
             </a:r>
             <a:endParaRPr lang="en-US" sz="1050" dirty="0"/>
           </a:p>

</xml_diff>